<commit_message>
feat: perf optimization + accessibility + EXE size reduction
- Add React.memo to all 10 components + useCallback optimization
- Add debounce (300ms) to note textarea in SubtaskSection
- Add ARIA attributes to checkboxes, keyboard edit (F2/Enter), focus-visible
- Remove dead code (save, replaceTodos, hideUndo)
- Fix ID generation: Date.now() → generateId() with counter
- Fix useUndo timeoutId: useState → useRef
- Optimize sortUtils: merge two-pass sort into single comparator
- Extract inline export function to utils.ts
- Fix keyboard shortcuts using refs instead of querySelector
- Fix ProgressBar to accept pre-computed values
- Add ErrorBoundary component
- Fix TypeScript types (any[] → Todo[])
- Move all deps to devDependencies for zero runtime deps
- EXE size: 131MB → 88MB (-33%)
- Update README.md and PPT with latest statistics
</commit_message>
<xml_diff>
--- a/ds_todo_presentation.pptx
+++ b/ds_todo_presentation.pptx
@@ -9601,7 +9601,7 @@
               </a:defRPr>
             </a:pPr>
             <a:r>
-              <a:t>131 MB</a:t>
+              <a:t>88 MB</a:t>
             </a:r>
           </a:p>
         </p:txBody>
@@ -11023,7 +11023,7 @@
               </a:defRPr>
             </a:pPr>
             <a:r>
-              <a:t>单文件 portable exe，双击启动，无需安装 Node.js / npm / 浏览器。131 MB 包含完整运行时。</a:t>
+              <a:t>单文件 portable exe，双击启动，无需安装 Node.js / npm / 浏览器。88 MB 包含完整运行时。</a:t>
             </a:r>
           </a:p>
         </p:txBody>
@@ -11515,7 +11515,7 @@
               </a:defRPr>
             </a:pPr>
             <a:r>
-              <a:t>131 MB 打包体积在 Electron 应用中属优秀水平（微软 To Do ~200 MB，Todoist ~250 MB）。</a:t>
+              <a:t>88 MB 打包体积在 Electron 应用中属优秀水平（微软 To Do ~200 MB，Todoist ~250 MB）。</a:t>
             </a:r>
           </a:p>
         </p:txBody>
@@ -12166,7 +12166,7 @@
               </a:defRPr>
             </a:pPr>
             <a:r>
-              <a:t>131 MB 虽然优于竞品，但相比 Native 应用 (如 Snipaste ~10 MB) 体积偏大。</a:t>
+              <a:t>88 MB 虽然优于竞品，但相比 Native 应用 (如 Snipaste ~10 MB) 体积偏大。</a:t>
             </a:r>
           </a:p>
         </p:txBody>
@@ -13270,7 +13270,7 @@
               </a:defRPr>
             </a:pPr>
             <a:r>
-              <a:t>代码架构清晰、注释克制、依赖极简（仅 framer-motion 一个运行时依赖）。19 个源文件覆盖 React/TypeScript/Tailwind/Electron 技术栈，是优秀的学习参考项目。</a:t>
+              <a:t>代码架构清晰、注释克制、依赖极简（零运行时依赖（完全静态导出））。20 个源文件覆盖 React/TypeScript/Tailwind/Electron 技术栈，是优秀的学习参考项目。</a:t>
             </a:r>
           </a:p>
         </p:txBody>
@@ -16727,7 +16727,7 @@
               </a:defRPr>
             </a:pPr>
             <a:r>
-              <a:t>131 MB</a:t>
+              <a:t>88 MB</a:t>
             </a:r>
           </a:p>
         </p:txBody>
@@ -22033,7 +22033,7 @@
               </a:defRPr>
             </a:pPr>
             <a:r>
-              <a:t>  ✓ ds_todo_portable.exe (131 MB) — 双击即用！</a:t>
+              <a:t>  ✓ ds_todo_portable.exe (88 MB) — 双击即用！</a:t>
             </a:r>
           </a:p>
         </p:txBody>
@@ -23290,7 +23290,7 @@
               </a:defRPr>
             </a:pPr>
             <a:r>
-              <a:t>131 MB</a:t>
+              <a:t>88 MB</a:t>
             </a:r>
           </a:p>
         </p:txBody>
@@ -29550,7 +29550,7 @@
               </a:defRPr>
             </a:pPr>
             <a:r>
-              <a:t>electron-builder 打包为 portable.exe (131 MB)</a:t>
+              <a:t>electron-builder 打包为 portable.exe (88 MB)</a:t>
             </a:r>
           </a:p>
         </p:txBody>
@@ -29929,7 +29929,7 @@
               </a:defRPr>
             </a:pPr>
             <a:r>
-              <a:t>组件层 (9 Components)</a:t>
+              <a:t>组件层 (10 Components)</a:t>
             </a:r>
           </a:p>
         </p:txBody>
@@ -31522,7 +31522,7 @@
               </a:defRPr>
             </a:pPr>
             <a:r>
-              <a:t>19 个源文件类型安全</a:t>
+              <a:t>20 个源文件类型安全</a:t>
             </a:r>
           </a:p>
         </p:txBody>
@@ -32438,7 +32438,7 @@
               </a:defRPr>
             </a:pPr>
             <a:r>
-              <a:t>不使用 Redux/Zustand/Jotai 等状态库，仅用 React useState + useCallback + props 传递实现完整状态流。依赖数量极简（仅 framer-motion 一个运行时依赖），代码透明可控，适合教学和二次开发。</a:t>
+              <a:t>不使用 Redux/Zustand/Jotai 等状态库，仅用 React useState + useCallback + props 传递实现完整状态流。依赖数量极简（零运行时依赖（完全静态导出）），代码透明可控，适合教学和二次开发。</a:t>
             </a:r>
           </a:p>
         </p:txBody>

</xml_diff>